<commit_message>
Evidencia rigor analitico: 4 hipoteses testadas e corrigidas
- README: nova secao com tabela de divergencias identificadas
- Notebook: celula de rigor analitico logo apos o cabecalho
- PPT: slide 13 dedicado ao processo de validacao vs hipoteses
- Documentos: autoria corrigida para Ana Raquel em todos os arquivos

Co-Authored-By: Claude Sonnet 4.6 <noreply@anthropic.com>
</commit_message>
<xml_diff>
--- a/Passos_Magicos_Datathon_POSTECH_DTAT.pptx
+++ b/Passos_Magicos_Datathon_POSTECH_DTAT.pptx
@@ -17,6 +17,7 @@
     <p:sldId id="265" r:id="rId16"/>
     <p:sldId id="266" r:id="rId17"/>
     <p:sldId id="267" r:id="rId18"/>
+    <p:sldId id="268" r:id="rId19"/>
   </p:sldIdLst>
   <p:sldSz cx="12188952" cy="6858000" type="screen4x3"/>
   <p:notesSz cx="6858000" cy="9144000"/>
@@ -7790,6 +7791,1828 @@
                 </a:solidFill>
               </a:rPr>
               <a:t>"Transformar a vida de crianças e jovens através da educação"</a:t>
+            </a:r>
+          </a:p>
+        </p:txBody>
+      </p:sp>
+    </p:spTree>
+  </p:cSld>
+  <p:clrMapOvr>
+    <a:masterClrMapping/>
+  </p:clrMapOvr>
+</p:sld>
+</file>
+
+<file path=ppt/slides/slide13.xml><?xml version="1.0" encoding="utf-8"?>
+<p:sld xmlns:a="http://schemas.openxmlformats.org/drawingml/2006/main" xmlns:p="http://schemas.openxmlformats.org/presentationml/2006/main" xmlns:r="http://schemas.openxmlformats.org/officeDocument/2006/relationships">
+  <p:cSld>
+    <p:bg>
+      <p:bgPr>
+        <a:solidFill>
+          <a:srgbClr val="0D1B2A"/>
+        </a:solidFill>
+        <a:effectLst/>
+      </p:bgPr>
+    </p:bg>
+    <p:spTree>
+      <p:nvGrpSpPr>
+        <p:cNvPr id="1" name=""/>
+        <p:cNvGrpSpPr/>
+        <p:nvPr/>
+      </p:nvGrpSpPr>
+      <p:grpSpPr/>
+      <p:sp>
+        <p:nvSpPr>
+          <p:cNvPr id="2" name="Rectangle 1"/>
+          <p:cNvSpPr/>
+          <p:nvPr/>
+        </p:nvSpPr>
+        <p:spPr>
+          <a:xfrm>
+            <a:off x="0" y="6583680"/>
+            <a:ext cx="12188952" cy="274320"/>
+          </a:xfrm>
+          <a:prstGeom prst="rect">
+            <a:avLst/>
+          </a:prstGeom>
+          <a:solidFill>
+            <a:srgbClr val="F39C12"/>
+          </a:solidFill>
+          <a:ln>
+            <a:noFill/>
+          </a:ln>
+        </p:spPr>
+        <p:style>
+          <a:lnRef idx="1">
+            <a:schemeClr val="accent1"/>
+          </a:lnRef>
+          <a:fillRef idx="3">
+            <a:schemeClr val="accent1"/>
+          </a:fillRef>
+          <a:effectRef idx="2">
+            <a:schemeClr val="accent1"/>
+          </a:effectRef>
+          <a:fontRef idx="minor">
+            <a:schemeClr val="lt1"/>
+          </a:fontRef>
+        </p:style>
+        <p:txBody>
+          <a:bodyPr rtlCol="0" anchor="ctr"/>
+          <a:lstStyle/>
+          <a:p>
+            <a:pPr algn="ctr"/>
+          </a:p>
+        </p:txBody>
+      </p:sp>
+      <p:sp>
+        <p:nvSpPr>
+          <p:cNvPr id="3" name="Rectangle 2"/>
+          <p:cNvSpPr/>
+          <p:nvPr/>
+        </p:nvSpPr>
+        <p:spPr>
+          <a:xfrm>
+            <a:off x="365760" y="274320"/>
+            <a:ext cx="2926080" cy="347472"/>
+          </a:xfrm>
+          <a:prstGeom prst="rect">
+            <a:avLst/>
+          </a:prstGeom>
+          <a:solidFill>
+            <a:srgbClr val="F39C12"/>
+          </a:solidFill>
+          <a:ln>
+            <a:noFill/>
+          </a:ln>
+        </p:spPr>
+        <p:style>
+          <a:lnRef idx="1">
+            <a:schemeClr val="accent1"/>
+          </a:lnRef>
+          <a:fillRef idx="3">
+            <a:schemeClr val="accent1"/>
+          </a:fillRef>
+          <a:effectRef idx="2">
+            <a:schemeClr val="accent1"/>
+          </a:effectRef>
+          <a:fontRef idx="minor">
+            <a:schemeClr val="lt1"/>
+          </a:fontRef>
+        </p:style>
+        <p:txBody>
+          <a:bodyPr rtlCol="0" anchor="ctr"/>
+          <a:lstStyle/>
+          <a:p>
+            <a:pPr algn="ctr"/>
+          </a:p>
+        </p:txBody>
+      </p:sp>
+      <p:sp>
+        <p:nvSpPr>
+          <p:cNvPr id="4" name="TextBox 3"/>
+          <p:cNvSpPr txBox="1"/>
+          <p:nvPr/>
+        </p:nvSpPr>
+        <p:spPr>
+          <a:xfrm>
+            <a:off x="457200" y="310896"/>
+            <a:ext cx="2743200" cy="292608"/>
+          </a:xfrm>
+          <a:prstGeom prst="rect">
+            <a:avLst/>
+          </a:prstGeom>
+          <a:noFill/>
+        </p:spPr>
+        <p:txBody>
+          <a:bodyPr wrap="square">
+            <a:spAutoFit/>
+          </a:bodyPr>
+          <a:lstStyle/>
+          <a:p>
+            <a:pPr algn="l"/>
+            <a:r>
+              <a:rPr sz="1200" b="1" i="0">
+                <a:solidFill>
+                  <a:srgbClr val="FFFFFF"/>
+                </a:solidFill>
+              </a:rPr>
+              <a:t>RIGOR ANALITICO</a:t>
+            </a:r>
+          </a:p>
+        </p:txBody>
+      </p:sp>
+      <p:sp>
+        <p:nvSpPr>
+          <p:cNvPr id="5" name="TextBox 4"/>
+          <p:cNvSpPr txBox="1"/>
+          <p:nvPr/>
+        </p:nvSpPr>
+        <p:spPr>
+          <a:xfrm>
+            <a:off x="365760" y="777240"/>
+            <a:ext cx="10972800" cy="594360"/>
+          </a:xfrm>
+          <a:prstGeom prst="rect">
+            <a:avLst/>
+          </a:prstGeom>
+          <a:noFill/>
+        </p:spPr>
+        <p:txBody>
+          <a:bodyPr wrap="square">
+            <a:spAutoFit/>
+          </a:bodyPr>
+          <a:lstStyle/>
+          <a:p>
+            <a:pPr algn="l"/>
+            <a:r>
+              <a:rPr sz="2800" b="1" i="0">
+                <a:solidFill>
+                  <a:srgbClr val="FFFFFF"/>
+                </a:solidFill>
+              </a:rPr>
+              <a:t>Hipoteses testadas. Conclusoes corrigidas pelos dados.</a:t>
+            </a:r>
+          </a:p>
+        </p:txBody>
+      </p:sp>
+      <p:sp>
+        <p:nvSpPr>
+          <p:cNvPr id="6" name="TextBox 5"/>
+          <p:cNvSpPr txBox="1"/>
+          <p:nvPr/>
+        </p:nvSpPr>
+        <p:spPr>
+          <a:xfrm>
+            <a:off x="365760" y="1463040"/>
+            <a:ext cx="10972800" cy="365760"/>
+          </a:xfrm>
+          <a:prstGeom prst="rect">
+            <a:avLst/>
+          </a:prstGeom>
+          <a:noFill/>
+        </p:spPr>
+        <p:txBody>
+          <a:bodyPr wrap="square">
+            <a:spAutoFit/>
+          </a:bodyPr>
+          <a:lstStyle/>
+          <a:p>
+            <a:pPr algn="l"/>
+            <a:r>
+              <a:rPr sz="1500" b="0" i="1">
+                <a:solidFill>
+                  <a:srgbClr val="CCD6E0"/>
+                </a:solidFill>
+              </a:rPr>
+              <a:t>Validacao estatistica independente identificou 4 divergencias materiais antes da versao final.</a:t>
+            </a:r>
+          </a:p>
+        </p:txBody>
+      </p:sp>
+      <p:sp>
+        <p:nvSpPr>
+          <p:cNvPr id="7" name="Rectangle 6"/>
+          <p:cNvSpPr/>
+          <p:nvPr/>
+        </p:nvSpPr>
+        <p:spPr>
+          <a:xfrm>
+            <a:off x="365760" y="2011680"/>
+            <a:ext cx="457200" cy="914400"/>
+          </a:xfrm>
+          <a:prstGeom prst="rect">
+            <a:avLst/>
+          </a:prstGeom>
+          <a:solidFill>
+            <a:srgbClr val="F39C12"/>
+          </a:solidFill>
+          <a:ln>
+            <a:noFill/>
+          </a:ln>
+        </p:spPr>
+        <p:style>
+          <a:lnRef idx="1">
+            <a:schemeClr val="accent1"/>
+          </a:lnRef>
+          <a:fillRef idx="3">
+            <a:schemeClr val="accent1"/>
+          </a:fillRef>
+          <a:effectRef idx="2">
+            <a:schemeClr val="accent1"/>
+          </a:effectRef>
+          <a:fontRef idx="minor">
+            <a:schemeClr val="lt1"/>
+          </a:fontRef>
+        </p:style>
+        <p:txBody>
+          <a:bodyPr rtlCol="0" anchor="ctr"/>
+          <a:lstStyle/>
+          <a:p>
+            <a:pPr algn="ctr"/>
+          </a:p>
+        </p:txBody>
+      </p:sp>
+      <p:sp>
+        <p:nvSpPr>
+          <p:cNvPr id="8" name="TextBox 7"/>
+          <p:cNvSpPr txBox="1"/>
+          <p:nvPr/>
+        </p:nvSpPr>
+        <p:spPr>
+          <a:xfrm>
+            <a:off x="365760" y="2267712"/>
+            <a:ext cx="457200" cy="457200"/>
+          </a:xfrm>
+          <a:prstGeom prst="rect">
+            <a:avLst/>
+          </a:prstGeom>
+          <a:noFill/>
+        </p:spPr>
+        <p:txBody>
+          <a:bodyPr wrap="square">
+            <a:spAutoFit/>
+          </a:bodyPr>
+          <a:lstStyle/>
+          <a:p>
+            <a:pPr algn="ctr"/>
+            <a:r>
+              <a:rPr sz="2200" b="1" i="0">
+                <a:solidFill>
+                  <a:srgbClr val="FFFFFF"/>
+                </a:solidFill>
+              </a:rPr>
+              <a:t>1</a:t>
+            </a:r>
+          </a:p>
+        </p:txBody>
+      </p:sp>
+      <p:sp>
+        <p:nvSpPr>
+          <p:cNvPr id="9" name="Rectangle 8"/>
+          <p:cNvSpPr/>
+          <p:nvPr/>
+        </p:nvSpPr>
+        <p:spPr>
+          <a:xfrm>
+            <a:off x="960120" y="2011680"/>
+            <a:ext cx="5029200" cy="914400"/>
+          </a:xfrm>
+          <a:prstGeom prst="rect">
+            <a:avLst/>
+          </a:prstGeom>
+          <a:solidFill>
+            <a:srgbClr val="1B355E"/>
+          </a:solidFill>
+          <a:ln>
+            <a:noFill/>
+          </a:ln>
+        </p:spPr>
+        <p:style>
+          <a:lnRef idx="1">
+            <a:schemeClr val="accent1"/>
+          </a:lnRef>
+          <a:fillRef idx="3">
+            <a:schemeClr val="accent1"/>
+          </a:fillRef>
+          <a:effectRef idx="2">
+            <a:schemeClr val="accent1"/>
+          </a:effectRef>
+          <a:fontRef idx="minor">
+            <a:schemeClr val="lt1"/>
+          </a:fontRef>
+        </p:style>
+        <p:txBody>
+          <a:bodyPr rtlCol="0" anchor="ctr"/>
+          <a:lstStyle/>
+          <a:p>
+            <a:pPr algn="ctr"/>
+          </a:p>
+        </p:txBody>
+      </p:sp>
+      <p:sp>
+        <p:nvSpPr>
+          <p:cNvPr id="10" name="Rectangle 9"/>
+          <p:cNvSpPr/>
+          <p:nvPr/>
+        </p:nvSpPr>
+        <p:spPr>
+          <a:xfrm>
+            <a:off x="960120" y="2011680"/>
+            <a:ext cx="5029200" cy="64008"/>
+          </a:xfrm>
+          <a:prstGeom prst="rect">
+            <a:avLst/>
+          </a:prstGeom>
+          <a:solidFill>
+            <a:srgbClr val="E74C3C"/>
+          </a:solidFill>
+          <a:ln>
+            <a:noFill/>
+          </a:ln>
+        </p:spPr>
+        <p:style>
+          <a:lnRef idx="1">
+            <a:schemeClr val="accent1"/>
+          </a:lnRef>
+          <a:fillRef idx="3">
+            <a:schemeClr val="accent1"/>
+          </a:fillRef>
+          <a:effectRef idx="2">
+            <a:schemeClr val="accent1"/>
+          </a:effectRef>
+          <a:fontRef idx="minor">
+            <a:schemeClr val="lt1"/>
+          </a:fontRef>
+        </p:style>
+        <p:txBody>
+          <a:bodyPr rtlCol="0" anchor="ctr"/>
+          <a:lstStyle/>
+          <a:p>
+            <a:pPr algn="ctr"/>
+          </a:p>
+        </p:txBody>
+      </p:sp>
+      <p:sp>
+        <p:nvSpPr>
+          <p:cNvPr id="11" name="TextBox 10"/>
+          <p:cNvSpPr txBox="1"/>
+          <p:nvPr/>
+        </p:nvSpPr>
+        <p:spPr>
+          <a:xfrm>
+            <a:off x="1051560" y="2084832"/>
+            <a:ext cx="4754880" cy="274320"/>
+          </a:xfrm>
+          <a:prstGeom prst="rect">
+            <a:avLst/>
+          </a:prstGeom>
+          <a:noFill/>
+        </p:spPr>
+        <p:txBody>
+          <a:bodyPr wrap="square">
+            <a:spAutoFit/>
+          </a:bodyPr>
+          <a:lstStyle/>
+          <a:p>
+            <a:pPr algn="l"/>
+            <a:r>
+              <a:rPr sz="1000" b="1" i="0">
+                <a:solidFill>
+                  <a:srgbClr val="E74C3C"/>
+                </a:solidFill>
+              </a:rPr>
+              <a:t>X  Hipotese inicial</a:t>
+            </a:r>
+          </a:p>
+        </p:txBody>
+      </p:sp>
+      <p:sp>
+        <p:nvSpPr>
+          <p:cNvPr id="12" name="TextBox 11"/>
+          <p:cNvSpPr txBox="1"/>
+          <p:nvPr/>
+        </p:nvSpPr>
+        <p:spPr>
+          <a:xfrm>
+            <a:off x="1051560" y="2359152"/>
+            <a:ext cx="4754880" cy="502920"/>
+          </a:xfrm>
+          <a:prstGeom prst="rect">
+            <a:avLst/>
+          </a:prstGeom>
+          <a:noFill/>
+        </p:spPr>
+        <p:txBody>
+          <a:bodyPr wrap="square">
+            <a:spAutoFit/>
+          </a:bodyPr>
+          <a:lstStyle/>
+          <a:p>
+            <a:pPr algn="l"/>
+            <a:r>
+              <a:rPr sz="1300" b="0" i="0">
+                <a:solidFill>
+                  <a:srgbClr val="CCD6E0"/>
+                </a:solidFill>
+              </a:rPr>
+              <a:t>IEG = principal diferenciador para bolsas</a:t>
+            </a:r>
+          </a:p>
+        </p:txBody>
+      </p:sp>
+      <p:sp>
+        <p:nvSpPr>
+          <p:cNvPr id="13" name="Rectangle 12"/>
+          <p:cNvSpPr/>
+          <p:nvPr/>
+        </p:nvSpPr>
+        <p:spPr>
+          <a:xfrm>
+            <a:off x="6172200" y="2011680"/>
+            <a:ext cx="5669280" cy="914400"/>
+          </a:xfrm>
+          <a:prstGeom prst="rect">
+            <a:avLst/>
+          </a:prstGeom>
+          <a:solidFill>
+            <a:srgbClr val="1B355E"/>
+          </a:solidFill>
+          <a:ln>
+            <a:noFill/>
+          </a:ln>
+        </p:spPr>
+        <p:style>
+          <a:lnRef idx="1">
+            <a:schemeClr val="accent1"/>
+          </a:lnRef>
+          <a:fillRef idx="3">
+            <a:schemeClr val="accent1"/>
+          </a:fillRef>
+          <a:effectRef idx="2">
+            <a:schemeClr val="accent1"/>
+          </a:effectRef>
+          <a:fontRef idx="minor">
+            <a:schemeClr val="lt1"/>
+          </a:fontRef>
+        </p:style>
+        <p:txBody>
+          <a:bodyPr rtlCol="0" anchor="ctr"/>
+          <a:lstStyle/>
+          <a:p>
+            <a:pPr algn="ctr"/>
+          </a:p>
+        </p:txBody>
+      </p:sp>
+      <p:sp>
+        <p:nvSpPr>
+          <p:cNvPr id="14" name="Rectangle 13"/>
+          <p:cNvSpPr/>
+          <p:nvPr/>
+        </p:nvSpPr>
+        <p:spPr>
+          <a:xfrm>
+            <a:off x="6172200" y="2011680"/>
+            <a:ext cx="5669280" cy="64008"/>
+          </a:xfrm>
+          <a:prstGeom prst="rect">
+            <a:avLst/>
+          </a:prstGeom>
+          <a:solidFill>
+            <a:srgbClr val="2ECC71"/>
+          </a:solidFill>
+          <a:ln>
+            <a:noFill/>
+          </a:ln>
+        </p:spPr>
+        <p:style>
+          <a:lnRef idx="1">
+            <a:schemeClr val="accent1"/>
+          </a:lnRef>
+          <a:fillRef idx="3">
+            <a:schemeClr val="accent1"/>
+          </a:fillRef>
+          <a:effectRef idx="2">
+            <a:schemeClr val="accent1"/>
+          </a:effectRef>
+          <a:fontRef idx="minor">
+            <a:schemeClr val="lt1"/>
+          </a:fontRef>
+        </p:style>
+        <p:txBody>
+          <a:bodyPr rtlCol="0" anchor="ctr"/>
+          <a:lstStyle/>
+          <a:p>
+            <a:pPr algn="ctr"/>
+          </a:p>
+        </p:txBody>
+      </p:sp>
+      <p:sp>
+        <p:nvSpPr>
+          <p:cNvPr id="15" name="TextBox 14"/>
+          <p:cNvSpPr txBox="1"/>
+          <p:nvPr/>
+        </p:nvSpPr>
+        <p:spPr>
+          <a:xfrm>
+            <a:off x="6263640" y="2084832"/>
+            <a:ext cx="5394960" cy="274320"/>
+          </a:xfrm>
+          <a:prstGeom prst="rect">
+            <a:avLst/>
+          </a:prstGeom>
+          <a:noFill/>
+        </p:spPr>
+        <p:txBody>
+          <a:bodyPr wrap="square">
+            <a:spAutoFit/>
+          </a:bodyPr>
+          <a:lstStyle/>
+          <a:p>
+            <a:pPr algn="l"/>
+            <a:r>
+              <a:rPr sz="1000" b="1" i="0">
+                <a:solidFill>
+                  <a:srgbClr val="2ECC71"/>
+                </a:solidFill>
+              </a:rPr>
+              <a:t>V  O que os dados mostraram</a:t>
+            </a:r>
+          </a:p>
+        </p:txBody>
+      </p:sp>
+      <p:sp>
+        <p:nvSpPr>
+          <p:cNvPr id="16" name="TextBox 15"/>
+          <p:cNvSpPr txBox="1"/>
+          <p:nvPr/>
+        </p:nvSpPr>
+        <p:spPr>
+          <a:xfrm>
+            <a:off x="6263640" y="2359152"/>
+            <a:ext cx="5394960" cy="502920"/>
+          </a:xfrm>
+          <a:prstGeom prst="rect">
+            <a:avLst/>
+          </a:prstGeom>
+          <a:noFill/>
+        </p:spPr>
+        <p:txBody>
+          <a:bodyPr wrap="square">
+            <a:spAutoFit/>
+          </a:bodyPr>
+          <a:lstStyle/>
+          <a:p>
+            <a:pPr algn="l"/>
+            <a:r>
+              <a:rPr sz="1300" b="0" i="0">
+                <a:solidFill>
+                  <a:srgbClr val="FFFFFF"/>
+                </a:solidFill>
+              </a:rPr>
+              <a:t>IEG e o ultimo (8 lugar). IPP (+0,987) e IDA (+0,944) lideram.</a:t>
+            </a:r>
+          </a:p>
+        </p:txBody>
+      </p:sp>
+      <p:sp>
+        <p:nvSpPr>
+          <p:cNvPr id="17" name="Rectangle 16"/>
+          <p:cNvSpPr/>
+          <p:nvPr/>
+        </p:nvSpPr>
+        <p:spPr>
+          <a:xfrm>
+            <a:off x="365760" y="3090672"/>
+            <a:ext cx="457200" cy="914400"/>
+          </a:xfrm>
+          <a:prstGeom prst="rect">
+            <a:avLst/>
+          </a:prstGeom>
+          <a:solidFill>
+            <a:srgbClr val="F39C12"/>
+          </a:solidFill>
+          <a:ln>
+            <a:noFill/>
+          </a:ln>
+        </p:spPr>
+        <p:style>
+          <a:lnRef idx="1">
+            <a:schemeClr val="accent1"/>
+          </a:lnRef>
+          <a:fillRef idx="3">
+            <a:schemeClr val="accent1"/>
+          </a:fillRef>
+          <a:effectRef idx="2">
+            <a:schemeClr val="accent1"/>
+          </a:effectRef>
+          <a:fontRef idx="minor">
+            <a:schemeClr val="lt1"/>
+          </a:fontRef>
+        </p:style>
+        <p:txBody>
+          <a:bodyPr rtlCol="0" anchor="ctr"/>
+          <a:lstStyle/>
+          <a:p>
+            <a:pPr algn="ctr"/>
+          </a:p>
+        </p:txBody>
+      </p:sp>
+      <p:sp>
+        <p:nvSpPr>
+          <p:cNvPr id="18" name="TextBox 17"/>
+          <p:cNvSpPr txBox="1"/>
+          <p:nvPr/>
+        </p:nvSpPr>
+        <p:spPr>
+          <a:xfrm>
+            <a:off x="365760" y="3346704"/>
+            <a:ext cx="457200" cy="457200"/>
+          </a:xfrm>
+          <a:prstGeom prst="rect">
+            <a:avLst/>
+          </a:prstGeom>
+          <a:noFill/>
+        </p:spPr>
+        <p:txBody>
+          <a:bodyPr wrap="square">
+            <a:spAutoFit/>
+          </a:bodyPr>
+          <a:lstStyle/>
+          <a:p>
+            <a:pPr algn="ctr"/>
+            <a:r>
+              <a:rPr sz="2200" b="1" i="0">
+                <a:solidFill>
+                  <a:srgbClr val="FFFFFF"/>
+                </a:solidFill>
+              </a:rPr>
+              <a:t>2</a:t>
+            </a:r>
+          </a:p>
+        </p:txBody>
+      </p:sp>
+      <p:sp>
+        <p:nvSpPr>
+          <p:cNvPr id="19" name="Rectangle 18"/>
+          <p:cNvSpPr/>
+          <p:nvPr/>
+        </p:nvSpPr>
+        <p:spPr>
+          <a:xfrm>
+            <a:off x="960120" y="3090672"/>
+            <a:ext cx="5029200" cy="914400"/>
+          </a:xfrm>
+          <a:prstGeom prst="rect">
+            <a:avLst/>
+          </a:prstGeom>
+          <a:solidFill>
+            <a:srgbClr val="1B355E"/>
+          </a:solidFill>
+          <a:ln>
+            <a:noFill/>
+          </a:ln>
+        </p:spPr>
+        <p:style>
+          <a:lnRef idx="1">
+            <a:schemeClr val="accent1"/>
+          </a:lnRef>
+          <a:fillRef idx="3">
+            <a:schemeClr val="accent1"/>
+          </a:fillRef>
+          <a:effectRef idx="2">
+            <a:schemeClr val="accent1"/>
+          </a:effectRef>
+          <a:fontRef idx="minor">
+            <a:schemeClr val="lt1"/>
+          </a:fontRef>
+        </p:style>
+        <p:txBody>
+          <a:bodyPr rtlCol="0" anchor="ctr"/>
+          <a:lstStyle/>
+          <a:p>
+            <a:pPr algn="ctr"/>
+          </a:p>
+        </p:txBody>
+      </p:sp>
+      <p:sp>
+        <p:nvSpPr>
+          <p:cNvPr id="20" name="Rectangle 19"/>
+          <p:cNvSpPr/>
+          <p:nvPr/>
+        </p:nvSpPr>
+        <p:spPr>
+          <a:xfrm>
+            <a:off x="960120" y="3090672"/>
+            <a:ext cx="5029200" cy="64008"/>
+          </a:xfrm>
+          <a:prstGeom prst="rect">
+            <a:avLst/>
+          </a:prstGeom>
+          <a:solidFill>
+            <a:srgbClr val="E74C3C"/>
+          </a:solidFill>
+          <a:ln>
+            <a:noFill/>
+          </a:ln>
+        </p:spPr>
+        <p:style>
+          <a:lnRef idx="1">
+            <a:schemeClr val="accent1"/>
+          </a:lnRef>
+          <a:fillRef idx="3">
+            <a:schemeClr val="accent1"/>
+          </a:fillRef>
+          <a:effectRef idx="2">
+            <a:schemeClr val="accent1"/>
+          </a:effectRef>
+          <a:fontRef idx="minor">
+            <a:schemeClr val="lt1"/>
+          </a:fontRef>
+        </p:style>
+        <p:txBody>
+          <a:bodyPr rtlCol="0" anchor="ctr"/>
+          <a:lstStyle/>
+          <a:p>
+            <a:pPr algn="ctr"/>
+          </a:p>
+        </p:txBody>
+      </p:sp>
+      <p:sp>
+        <p:nvSpPr>
+          <p:cNvPr id="21" name="TextBox 20"/>
+          <p:cNvSpPr txBox="1"/>
+          <p:nvPr/>
+        </p:nvSpPr>
+        <p:spPr>
+          <a:xfrm>
+            <a:off x="1051560" y="3163824"/>
+            <a:ext cx="4754880" cy="274320"/>
+          </a:xfrm>
+          <a:prstGeom prst="rect">
+            <a:avLst/>
+          </a:prstGeom>
+          <a:noFill/>
+        </p:spPr>
+        <p:txBody>
+          <a:bodyPr wrap="square">
+            <a:spAutoFit/>
+          </a:bodyPr>
+          <a:lstStyle/>
+          <a:p>
+            <a:pPr algn="l"/>
+            <a:r>
+              <a:rPr sz="1000" b="1" i="0">
+                <a:solidFill>
+                  <a:srgbClr val="E74C3C"/>
+                </a:solidFill>
+              </a:rPr>
+              <a:t>X  Hipotese inicial</a:t>
+            </a:r>
+          </a:p>
+        </p:txBody>
+      </p:sp>
+      <p:sp>
+        <p:nvSpPr>
+          <p:cNvPr id="22" name="TextBox 21"/>
+          <p:cNvSpPr txBox="1"/>
+          <p:nvPr/>
+        </p:nvSpPr>
+        <p:spPr>
+          <a:xfrm>
+            <a:off x="1051560" y="3438144"/>
+            <a:ext cx="4754880" cy="502920"/>
+          </a:xfrm>
+          <a:prstGeom prst="rect">
+            <a:avLst/>
+          </a:prstGeom>
+          <a:noFill/>
+        </p:spPr>
+        <p:txBody>
+          <a:bodyPr wrap="square">
+            <a:spAutoFit/>
+          </a:bodyPr>
+          <a:lstStyle/>
+          <a:p>
+            <a:pPr algn="l"/>
+            <a:r>
+              <a:rPr sz="1300" b="0" i="0">
+                <a:solidFill>
+                  <a:srgbClr val="CCD6E0"/>
+                </a:solidFill>
+              </a:rPr>
+              <a:t>Mais anos no programa maior INDE</a:t>
+            </a:r>
+          </a:p>
+        </p:txBody>
+      </p:sp>
+      <p:sp>
+        <p:nvSpPr>
+          <p:cNvPr id="23" name="Rectangle 22"/>
+          <p:cNvSpPr/>
+          <p:nvPr/>
+        </p:nvSpPr>
+        <p:spPr>
+          <a:xfrm>
+            <a:off x="6172200" y="3090672"/>
+            <a:ext cx="5669280" cy="914400"/>
+          </a:xfrm>
+          <a:prstGeom prst="rect">
+            <a:avLst/>
+          </a:prstGeom>
+          <a:solidFill>
+            <a:srgbClr val="1B355E"/>
+          </a:solidFill>
+          <a:ln>
+            <a:noFill/>
+          </a:ln>
+        </p:spPr>
+        <p:style>
+          <a:lnRef idx="1">
+            <a:schemeClr val="accent1"/>
+          </a:lnRef>
+          <a:fillRef idx="3">
+            <a:schemeClr val="accent1"/>
+          </a:fillRef>
+          <a:effectRef idx="2">
+            <a:schemeClr val="accent1"/>
+          </a:effectRef>
+          <a:fontRef idx="minor">
+            <a:schemeClr val="lt1"/>
+          </a:fontRef>
+        </p:style>
+        <p:txBody>
+          <a:bodyPr rtlCol="0" anchor="ctr"/>
+          <a:lstStyle/>
+          <a:p>
+            <a:pPr algn="ctr"/>
+          </a:p>
+        </p:txBody>
+      </p:sp>
+      <p:sp>
+        <p:nvSpPr>
+          <p:cNvPr id="24" name="Rectangle 23"/>
+          <p:cNvSpPr/>
+          <p:nvPr/>
+        </p:nvSpPr>
+        <p:spPr>
+          <a:xfrm>
+            <a:off x="6172200" y="3090672"/>
+            <a:ext cx="5669280" cy="64008"/>
+          </a:xfrm>
+          <a:prstGeom prst="rect">
+            <a:avLst/>
+          </a:prstGeom>
+          <a:solidFill>
+            <a:srgbClr val="2ECC71"/>
+          </a:solidFill>
+          <a:ln>
+            <a:noFill/>
+          </a:ln>
+        </p:spPr>
+        <p:style>
+          <a:lnRef idx="1">
+            <a:schemeClr val="accent1"/>
+          </a:lnRef>
+          <a:fillRef idx="3">
+            <a:schemeClr val="accent1"/>
+          </a:fillRef>
+          <a:effectRef idx="2">
+            <a:schemeClr val="accent1"/>
+          </a:effectRef>
+          <a:fontRef idx="minor">
+            <a:schemeClr val="lt1"/>
+          </a:fontRef>
+        </p:style>
+        <p:txBody>
+          <a:bodyPr rtlCol="0" anchor="ctr"/>
+          <a:lstStyle/>
+          <a:p>
+            <a:pPr algn="ctr"/>
+          </a:p>
+        </p:txBody>
+      </p:sp>
+      <p:sp>
+        <p:nvSpPr>
+          <p:cNvPr id="25" name="TextBox 24"/>
+          <p:cNvSpPr txBox="1"/>
+          <p:nvPr/>
+        </p:nvSpPr>
+        <p:spPr>
+          <a:xfrm>
+            <a:off x="6263640" y="3163824"/>
+            <a:ext cx="5394960" cy="274320"/>
+          </a:xfrm>
+          <a:prstGeom prst="rect">
+            <a:avLst/>
+          </a:prstGeom>
+          <a:noFill/>
+        </p:spPr>
+        <p:txBody>
+          <a:bodyPr wrap="square">
+            <a:spAutoFit/>
+          </a:bodyPr>
+          <a:lstStyle/>
+          <a:p>
+            <a:pPr algn="l"/>
+            <a:r>
+              <a:rPr sz="1000" b="1" i="0">
+                <a:solidFill>
+                  <a:srgbClr val="2ECC71"/>
+                </a:solidFill>
+              </a:rPr>
+              <a:t>V  O que os dados mostraram</a:t>
+            </a:r>
+          </a:p>
+        </p:txBody>
+      </p:sp>
+      <p:sp>
+        <p:nvSpPr>
+          <p:cNvPr id="26" name="TextBox 25"/>
+          <p:cNvSpPr txBox="1"/>
+          <p:nvPr/>
+        </p:nvSpPr>
+        <p:spPr>
+          <a:xfrm>
+            <a:off x="6263640" y="3438144"/>
+            <a:ext cx="5394960" cy="502920"/>
+          </a:xfrm>
+          <a:prstGeom prst="rect">
+            <a:avLst/>
+          </a:prstGeom>
+          <a:noFill/>
+        </p:spPr>
+        <p:txBody>
+          <a:bodyPr wrap="square">
+            <a:spAutoFit/>
+          </a:bodyPr>
+          <a:lstStyle/>
+          <a:p>
+            <a:pPr algn="l"/>
+            <a:r>
+              <a:rPr sz="1300" b="0" i="0">
+                <a:solidFill>
+                  <a:srgbClr val="FFFFFF"/>
+                </a:solidFill>
+              </a:rPr>
+              <a:t>Spearman r=-0,075, p=0,176 nao significativo.</a:t>
+            </a:r>
+          </a:p>
+        </p:txBody>
+      </p:sp>
+      <p:sp>
+        <p:nvSpPr>
+          <p:cNvPr id="27" name="Rectangle 26"/>
+          <p:cNvSpPr/>
+          <p:nvPr/>
+        </p:nvSpPr>
+        <p:spPr>
+          <a:xfrm>
+            <a:off x="365760" y="4169664"/>
+            <a:ext cx="457200" cy="914400"/>
+          </a:xfrm>
+          <a:prstGeom prst="rect">
+            <a:avLst/>
+          </a:prstGeom>
+          <a:solidFill>
+            <a:srgbClr val="F39C12"/>
+          </a:solidFill>
+          <a:ln>
+            <a:noFill/>
+          </a:ln>
+        </p:spPr>
+        <p:style>
+          <a:lnRef idx="1">
+            <a:schemeClr val="accent1"/>
+          </a:lnRef>
+          <a:fillRef idx="3">
+            <a:schemeClr val="accent1"/>
+          </a:fillRef>
+          <a:effectRef idx="2">
+            <a:schemeClr val="accent1"/>
+          </a:effectRef>
+          <a:fontRef idx="minor">
+            <a:schemeClr val="lt1"/>
+          </a:fontRef>
+        </p:style>
+        <p:txBody>
+          <a:bodyPr rtlCol="0" anchor="ctr"/>
+          <a:lstStyle/>
+          <a:p>
+            <a:pPr algn="ctr"/>
+          </a:p>
+        </p:txBody>
+      </p:sp>
+      <p:sp>
+        <p:nvSpPr>
+          <p:cNvPr id="28" name="TextBox 27"/>
+          <p:cNvSpPr txBox="1"/>
+          <p:nvPr/>
+        </p:nvSpPr>
+        <p:spPr>
+          <a:xfrm>
+            <a:off x="365760" y="4425696"/>
+            <a:ext cx="457200" cy="457200"/>
+          </a:xfrm>
+          <a:prstGeom prst="rect">
+            <a:avLst/>
+          </a:prstGeom>
+          <a:noFill/>
+        </p:spPr>
+        <p:txBody>
+          <a:bodyPr wrap="square">
+            <a:spAutoFit/>
+          </a:bodyPr>
+          <a:lstStyle/>
+          <a:p>
+            <a:pPr algn="ctr"/>
+            <a:r>
+              <a:rPr sz="2200" b="1" i="0">
+                <a:solidFill>
+                  <a:srgbClr val="FFFFFF"/>
+                </a:solidFill>
+              </a:rPr>
+              <a:t>3</a:t>
+            </a:r>
+          </a:p>
+        </p:txBody>
+      </p:sp>
+      <p:sp>
+        <p:nvSpPr>
+          <p:cNvPr id="29" name="Rectangle 28"/>
+          <p:cNvSpPr/>
+          <p:nvPr/>
+        </p:nvSpPr>
+        <p:spPr>
+          <a:xfrm>
+            <a:off x="960120" y="4169664"/>
+            <a:ext cx="5029200" cy="914400"/>
+          </a:xfrm>
+          <a:prstGeom prst="rect">
+            <a:avLst/>
+          </a:prstGeom>
+          <a:solidFill>
+            <a:srgbClr val="1B355E"/>
+          </a:solidFill>
+          <a:ln>
+            <a:noFill/>
+          </a:ln>
+        </p:spPr>
+        <p:style>
+          <a:lnRef idx="1">
+            <a:schemeClr val="accent1"/>
+          </a:lnRef>
+          <a:fillRef idx="3">
+            <a:schemeClr val="accent1"/>
+          </a:fillRef>
+          <a:effectRef idx="2">
+            <a:schemeClr val="accent1"/>
+          </a:effectRef>
+          <a:fontRef idx="minor">
+            <a:schemeClr val="lt1"/>
+          </a:fontRef>
+        </p:style>
+        <p:txBody>
+          <a:bodyPr rtlCol="0" anchor="ctr"/>
+          <a:lstStyle/>
+          <a:p>
+            <a:pPr algn="ctr"/>
+          </a:p>
+        </p:txBody>
+      </p:sp>
+      <p:sp>
+        <p:nvSpPr>
+          <p:cNvPr id="30" name="Rectangle 29"/>
+          <p:cNvSpPr/>
+          <p:nvPr/>
+        </p:nvSpPr>
+        <p:spPr>
+          <a:xfrm>
+            <a:off x="960120" y="4169664"/>
+            <a:ext cx="5029200" cy="64008"/>
+          </a:xfrm>
+          <a:prstGeom prst="rect">
+            <a:avLst/>
+          </a:prstGeom>
+          <a:solidFill>
+            <a:srgbClr val="E74C3C"/>
+          </a:solidFill>
+          <a:ln>
+            <a:noFill/>
+          </a:ln>
+        </p:spPr>
+        <p:style>
+          <a:lnRef idx="1">
+            <a:schemeClr val="accent1"/>
+          </a:lnRef>
+          <a:fillRef idx="3">
+            <a:schemeClr val="accent1"/>
+          </a:fillRef>
+          <a:effectRef idx="2">
+            <a:schemeClr val="accent1"/>
+          </a:effectRef>
+          <a:fontRef idx="minor">
+            <a:schemeClr val="lt1"/>
+          </a:fontRef>
+        </p:style>
+        <p:txBody>
+          <a:bodyPr rtlCol="0" anchor="ctr"/>
+          <a:lstStyle/>
+          <a:p>
+            <a:pPr algn="ctr"/>
+          </a:p>
+        </p:txBody>
+      </p:sp>
+      <p:sp>
+        <p:nvSpPr>
+          <p:cNvPr id="31" name="TextBox 30"/>
+          <p:cNvSpPr txBox="1"/>
+          <p:nvPr/>
+        </p:nvSpPr>
+        <p:spPr>
+          <a:xfrm>
+            <a:off x="1051560" y="4242816"/>
+            <a:ext cx="4754880" cy="274320"/>
+          </a:xfrm>
+          <a:prstGeom prst="rect">
+            <a:avLst/>
+          </a:prstGeom>
+          <a:noFill/>
+        </p:spPr>
+        <p:txBody>
+          <a:bodyPr wrap="square">
+            <a:spAutoFit/>
+          </a:bodyPr>
+          <a:lstStyle/>
+          <a:p>
+            <a:pPr algn="l"/>
+            <a:r>
+              <a:rPr sz="1000" b="1" i="0">
+                <a:solidFill>
+                  <a:srgbClr val="E74C3C"/>
+                </a:solidFill>
+              </a:rPr>
+              <a:t>X  Hipotese inicial</a:t>
+            </a:r>
+          </a:p>
+        </p:txBody>
+      </p:sp>
+      <p:sp>
+        <p:nvSpPr>
+          <p:cNvPr id="32" name="TextBox 31"/>
+          <p:cNvSpPr txBox="1"/>
+          <p:nvPr/>
+        </p:nvSpPr>
+        <p:spPr>
+          <a:xfrm>
+            <a:off x="1051560" y="4517136"/>
+            <a:ext cx="4754880" cy="502920"/>
+          </a:xfrm>
+          <a:prstGeom prst="rect">
+            <a:avLst/>
+          </a:prstGeom>
+          <a:noFill/>
+        </p:spPr>
+        <p:txBody>
+          <a:bodyPr wrap="square">
+            <a:spAutoFit/>
+          </a:bodyPr>
+          <a:lstStyle/>
+          <a:p>
+            <a:pPr algn="l"/>
+            <a:r>
+              <a:rPr sz="1300" b="0" i="0">
+                <a:solidFill>
+                  <a:srgbClr val="CCD6E0"/>
+                </a:solidFill>
+              </a:rPr>
+              <a:t>Escola publica = principal grupo de indicados</a:t>
+            </a:r>
+          </a:p>
+        </p:txBody>
+      </p:sp>
+      <p:sp>
+        <p:nvSpPr>
+          <p:cNvPr id="33" name="Rectangle 32"/>
+          <p:cNvSpPr/>
+          <p:nvPr/>
+        </p:nvSpPr>
+        <p:spPr>
+          <a:xfrm>
+            <a:off x="6172200" y="4169664"/>
+            <a:ext cx="5669280" cy="914400"/>
+          </a:xfrm>
+          <a:prstGeom prst="rect">
+            <a:avLst/>
+          </a:prstGeom>
+          <a:solidFill>
+            <a:srgbClr val="1B355E"/>
+          </a:solidFill>
+          <a:ln>
+            <a:noFill/>
+          </a:ln>
+        </p:spPr>
+        <p:style>
+          <a:lnRef idx="1">
+            <a:schemeClr val="accent1"/>
+          </a:lnRef>
+          <a:fillRef idx="3">
+            <a:schemeClr val="accent1"/>
+          </a:fillRef>
+          <a:effectRef idx="2">
+            <a:schemeClr val="accent1"/>
+          </a:effectRef>
+          <a:fontRef idx="minor">
+            <a:schemeClr val="lt1"/>
+          </a:fontRef>
+        </p:style>
+        <p:txBody>
+          <a:bodyPr rtlCol="0" anchor="ctr"/>
+          <a:lstStyle/>
+          <a:p>
+            <a:pPr algn="ctr"/>
+          </a:p>
+        </p:txBody>
+      </p:sp>
+      <p:sp>
+        <p:nvSpPr>
+          <p:cNvPr id="34" name="Rectangle 33"/>
+          <p:cNvSpPr/>
+          <p:nvPr/>
+        </p:nvSpPr>
+        <p:spPr>
+          <a:xfrm>
+            <a:off x="6172200" y="4169664"/>
+            <a:ext cx="5669280" cy="64008"/>
+          </a:xfrm>
+          <a:prstGeom prst="rect">
+            <a:avLst/>
+          </a:prstGeom>
+          <a:solidFill>
+            <a:srgbClr val="2ECC71"/>
+          </a:solidFill>
+          <a:ln>
+            <a:noFill/>
+          </a:ln>
+        </p:spPr>
+        <p:style>
+          <a:lnRef idx="1">
+            <a:schemeClr val="accent1"/>
+          </a:lnRef>
+          <a:fillRef idx="3">
+            <a:schemeClr val="accent1"/>
+          </a:fillRef>
+          <a:effectRef idx="2">
+            <a:schemeClr val="accent1"/>
+          </a:effectRef>
+          <a:fontRef idx="minor">
+            <a:schemeClr val="lt1"/>
+          </a:fontRef>
+        </p:style>
+        <p:txBody>
+          <a:bodyPr rtlCol="0" anchor="ctr"/>
+          <a:lstStyle/>
+          <a:p>
+            <a:pPr algn="ctr"/>
+          </a:p>
+        </p:txBody>
+      </p:sp>
+      <p:sp>
+        <p:nvSpPr>
+          <p:cNvPr id="35" name="TextBox 34"/>
+          <p:cNvSpPr txBox="1"/>
+          <p:nvPr/>
+        </p:nvSpPr>
+        <p:spPr>
+          <a:xfrm>
+            <a:off x="6263640" y="4242816"/>
+            <a:ext cx="5394960" cy="274320"/>
+          </a:xfrm>
+          <a:prstGeom prst="rect">
+            <a:avLst/>
+          </a:prstGeom>
+          <a:noFill/>
+        </p:spPr>
+        <p:txBody>
+          <a:bodyPr wrap="square">
+            <a:spAutoFit/>
+          </a:bodyPr>
+          <a:lstStyle/>
+          <a:p>
+            <a:pPr algn="l"/>
+            <a:r>
+              <a:rPr sz="1000" b="1" i="0">
+                <a:solidFill>
+                  <a:srgbClr val="2ECC71"/>
+                </a:solidFill>
+              </a:rPr>
+              <a:t>V  O que os dados mostraram</a:t>
+            </a:r>
+          </a:p>
+        </p:txBody>
+      </p:sp>
+      <p:sp>
+        <p:nvSpPr>
+          <p:cNvPr id="36" name="TextBox 35"/>
+          <p:cNvSpPr txBox="1"/>
+          <p:nvPr/>
+        </p:nvSpPr>
+        <p:spPr>
+          <a:xfrm>
+            <a:off x="6263640" y="4517136"/>
+            <a:ext cx="5394960" cy="502920"/>
+          </a:xfrm>
+          <a:prstGeom prst="rect">
+            <a:avLst/>
+          </a:prstGeom>
+          <a:noFill/>
+        </p:spPr>
+        <p:txBody>
+          <a:bodyPr wrap="square">
+            <a:spAutoFit/>
+          </a:bodyPr>
+          <a:lstStyle/>
+          <a:p>
+            <a:pPr algn="l"/>
+            <a:r>
+              <a:rPr sz="1300" b="0" i="0">
+                <a:solidFill>
+                  <a:srgbClr val="FFFFFF"/>
+                </a:solidFill>
+              </a:rPr>
+              <a:t>61,4% dos indicados vem de escola privada.</a:t>
+            </a:r>
+          </a:p>
+        </p:txBody>
+      </p:sp>
+      <p:sp>
+        <p:nvSpPr>
+          <p:cNvPr id="37" name="Rectangle 36"/>
+          <p:cNvSpPr/>
+          <p:nvPr/>
+        </p:nvSpPr>
+        <p:spPr>
+          <a:xfrm>
+            <a:off x="365760" y="5248656"/>
+            <a:ext cx="457200" cy="914400"/>
+          </a:xfrm>
+          <a:prstGeom prst="rect">
+            <a:avLst/>
+          </a:prstGeom>
+          <a:solidFill>
+            <a:srgbClr val="F39C12"/>
+          </a:solidFill>
+          <a:ln>
+            <a:noFill/>
+          </a:ln>
+        </p:spPr>
+        <p:style>
+          <a:lnRef idx="1">
+            <a:schemeClr val="accent1"/>
+          </a:lnRef>
+          <a:fillRef idx="3">
+            <a:schemeClr val="accent1"/>
+          </a:fillRef>
+          <a:effectRef idx="2">
+            <a:schemeClr val="accent1"/>
+          </a:effectRef>
+          <a:fontRef idx="minor">
+            <a:schemeClr val="lt1"/>
+          </a:fontRef>
+        </p:style>
+        <p:txBody>
+          <a:bodyPr rtlCol="0" anchor="ctr"/>
+          <a:lstStyle/>
+          <a:p>
+            <a:pPr algn="ctr"/>
+          </a:p>
+        </p:txBody>
+      </p:sp>
+      <p:sp>
+        <p:nvSpPr>
+          <p:cNvPr id="38" name="TextBox 37"/>
+          <p:cNvSpPr txBox="1"/>
+          <p:nvPr/>
+        </p:nvSpPr>
+        <p:spPr>
+          <a:xfrm>
+            <a:off x="365760" y="5504688"/>
+            <a:ext cx="457200" cy="457200"/>
+          </a:xfrm>
+          <a:prstGeom prst="rect">
+            <a:avLst/>
+          </a:prstGeom>
+          <a:noFill/>
+        </p:spPr>
+        <p:txBody>
+          <a:bodyPr wrap="square">
+            <a:spAutoFit/>
+          </a:bodyPr>
+          <a:lstStyle/>
+          <a:p>
+            <a:pPr algn="ctr"/>
+            <a:r>
+              <a:rPr sz="2200" b="1" i="0">
+                <a:solidFill>
+                  <a:srgbClr val="FFFFFF"/>
+                </a:solidFill>
+              </a:rPr>
+              <a:t>4</a:t>
+            </a:r>
+          </a:p>
+        </p:txBody>
+      </p:sp>
+      <p:sp>
+        <p:nvSpPr>
+          <p:cNvPr id="39" name="Rectangle 38"/>
+          <p:cNvSpPr/>
+          <p:nvPr/>
+        </p:nvSpPr>
+        <p:spPr>
+          <a:xfrm>
+            <a:off x="960120" y="5248656"/>
+            <a:ext cx="5029200" cy="914400"/>
+          </a:xfrm>
+          <a:prstGeom prst="rect">
+            <a:avLst/>
+          </a:prstGeom>
+          <a:solidFill>
+            <a:srgbClr val="1B355E"/>
+          </a:solidFill>
+          <a:ln>
+            <a:noFill/>
+          </a:ln>
+        </p:spPr>
+        <p:style>
+          <a:lnRef idx="1">
+            <a:schemeClr val="accent1"/>
+          </a:lnRef>
+          <a:fillRef idx="3">
+            <a:schemeClr val="accent1"/>
+          </a:fillRef>
+          <a:effectRef idx="2">
+            <a:schemeClr val="accent1"/>
+          </a:effectRef>
+          <a:fontRef idx="minor">
+            <a:schemeClr val="lt1"/>
+          </a:fontRef>
+        </p:style>
+        <p:txBody>
+          <a:bodyPr rtlCol="0" anchor="ctr"/>
+          <a:lstStyle/>
+          <a:p>
+            <a:pPr algn="ctr"/>
+          </a:p>
+        </p:txBody>
+      </p:sp>
+      <p:sp>
+        <p:nvSpPr>
+          <p:cNvPr id="40" name="Rectangle 39"/>
+          <p:cNvSpPr/>
+          <p:nvPr/>
+        </p:nvSpPr>
+        <p:spPr>
+          <a:xfrm>
+            <a:off x="960120" y="5248656"/>
+            <a:ext cx="5029200" cy="64008"/>
+          </a:xfrm>
+          <a:prstGeom prst="rect">
+            <a:avLst/>
+          </a:prstGeom>
+          <a:solidFill>
+            <a:srgbClr val="E74C3C"/>
+          </a:solidFill>
+          <a:ln>
+            <a:noFill/>
+          </a:ln>
+        </p:spPr>
+        <p:style>
+          <a:lnRef idx="1">
+            <a:schemeClr val="accent1"/>
+          </a:lnRef>
+          <a:fillRef idx="3">
+            <a:schemeClr val="accent1"/>
+          </a:fillRef>
+          <a:effectRef idx="2">
+            <a:schemeClr val="accent1"/>
+          </a:effectRef>
+          <a:fontRef idx="minor">
+            <a:schemeClr val="lt1"/>
+          </a:fontRef>
+        </p:style>
+        <p:txBody>
+          <a:bodyPr rtlCol="0" anchor="ctr"/>
+          <a:lstStyle/>
+          <a:p>
+            <a:pPr algn="ctr"/>
+          </a:p>
+        </p:txBody>
+      </p:sp>
+      <p:sp>
+        <p:nvSpPr>
+          <p:cNvPr id="41" name="TextBox 40"/>
+          <p:cNvSpPr txBox="1"/>
+          <p:nvPr/>
+        </p:nvSpPr>
+        <p:spPr>
+          <a:xfrm>
+            <a:off x="1051560" y="5321808"/>
+            <a:ext cx="4754880" cy="274320"/>
+          </a:xfrm>
+          <a:prstGeom prst="rect">
+            <a:avLst/>
+          </a:prstGeom>
+          <a:noFill/>
+        </p:spPr>
+        <p:txBody>
+          <a:bodyPr wrap="square">
+            <a:spAutoFit/>
+          </a:bodyPr>
+          <a:lstStyle/>
+          <a:p>
+            <a:pPr algn="l"/>
+            <a:r>
+              <a:rPr sz="1000" b="1" i="0">
+                <a:solidFill>
+                  <a:srgbClr val="E74C3C"/>
+                </a:solidFill>
+              </a:rPr>
+              <a:t>X  Hipotese inicial</a:t>
+            </a:r>
+          </a:p>
+        </p:txBody>
+      </p:sp>
+      <p:sp>
+        <p:nvSpPr>
+          <p:cNvPr id="42" name="TextBox 41"/>
+          <p:cNvSpPr txBox="1"/>
+          <p:nvPr/>
+        </p:nvSpPr>
+        <p:spPr>
+          <a:xfrm>
+            <a:off x="1051560" y="5596128"/>
+            <a:ext cx="4754880" cy="502920"/>
+          </a:xfrm>
+          <a:prstGeom prst="rect">
+            <a:avLst/>
+          </a:prstGeom>
+          <a:noFill/>
+        </p:spPr>
+        <p:txBody>
+          <a:bodyPr wrap="square">
+            <a:spAutoFit/>
+          </a:bodyPr>
+          <a:lstStyle/>
+          <a:p>
+            <a:pPr algn="l"/>
+            <a:r>
+              <a:rPr sz="1300" b="0" i="0">
+                <a:solidFill>
+                  <a:srgbClr val="CCD6E0"/>
+                </a:solidFill>
+              </a:rPr>
+              <a:t>INDE cresceu consistentemente 2020-2022</a:t>
+            </a:r>
+          </a:p>
+        </p:txBody>
+      </p:sp>
+      <p:sp>
+        <p:nvSpPr>
+          <p:cNvPr id="43" name="Rectangle 42"/>
+          <p:cNvSpPr/>
+          <p:nvPr/>
+        </p:nvSpPr>
+        <p:spPr>
+          <a:xfrm>
+            <a:off x="6172200" y="5248656"/>
+            <a:ext cx="5669280" cy="914400"/>
+          </a:xfrm>
+          <a:prstGeom prst="rect">
+            <a:avLst/>
+          </a:prstGeom>
+          <a:solidFill>
+            <a:srgbClr val="1B355E"/>
+          </a:solidFill>
+          <a:ln>
+            <a:noFill/>
+          </a:ln>
+        </p:spPr>
+        <p:style>
+          <a:lnRef idx="1">
+            <a:schemeClr val="accent1"/>
+          </a:lnRef>
+          <a:fillRef idx="3">
+            <a:schemeClr val="accent1"/>
+          </a:fillRef>
+          <a:effectRef idx="2">
+            <a:schemeClr val="accent1"/>
+          </a:effectRef>
+          <a:fontRef idx="minor">
+            <a:schemeClr val="lt1"/>
+          </a:fontRef>
+        </p:style>
+        <p:txBody>
+          <a:bodyPr rtlCol="0" anchor="ctr"/>
+          <a:lstStyle/>
+          <a:p>
+            <a:pPr algn="ctr"/>
+          </a:p>
+        </p:txBody>
+      </p:sp>
+      <p:sp>
+        <p:nvSpPr>
+          <p:cNvPr id="44" name="Rectangle 43"/>
+          <p:cNvSpPr/>
+          <p:nvPr/>
+        </p:nvSpPr>
+        <p:spPr>
+          <a:xfrm>
+            <a:off x="6172200" y="5248656"/>
+            <a:ext cx="5669280" cy="64008"/>
+          </a:xfrm>
+          <a:prstGeom prst="rect">
+            <a:avLst/>
+          </a:prstGeom>
+          <a:solidFill>
+            <a:srgbClr val="2ECC71"/>
+          </a:solidFill>
+          <a:ln>
+            <a:noFill/>
+          </a:ln>
+        </p:spPr>
+        <p:style>
+          <a:lnRef idx="1">
+            <a:schemeClr val="accent1"/>
+          </a:lnRef>
+          <a:fillRef idx="3">
+            <a:schemeClr val="accent1"/>
+          </a:fillRef>
+          <a:effectRef idx="2">
+            <a:schemeClr val="accent1"/>
+          </a:effectRef>
+          <a:fontRef idx="minor">
+            <a:schemeClr val="lt1"/>
+          </a:fontRef>
+        </p:style>
+        <p:txBody>
+          <a:bodyPr rtlCol="0" anchor="ctr"/>
+          <a:lstStyle/>
+          <a:p>
+            <a:pPr algn="ctr"/>
+          </a:p>
+        </p:txBody>
+      </p:sp>
+      <p:sp>
+        <p:nvSpPr>
+          <p:cNvPr id="45" name="TextBox 44"/>
+          <p:cNvSpPr txBox="1"/>
+          <p:nvPr/>
+        </p:nvSpPr>
+        <p:spPr>
+          <a:xfrm>
+            <a:off x="6263640" y="5321808"/>
+            <a:ext cx="5394960" cy="274320"/>
+          </a:xfrm>
+          <a:prstGeom prst="rect">
+            <a:avLst/>
+          </a:prstGeom>
+          <a:noFill/>
+        </p:spPr>
+        <p:txBody>
+          <a:bodyPr wrap="square">
+            <a:spAutoFit/>
+          </a:bodyPr>
+          <a:lstStyle/>
+          <a:p>
+            <a:pPr algn="l"/>
+            <a:r>
+              <a:rPr sz="1000" b="1" i="0">
+                <a:solidFill>
+                  <a:srgbClr val="2ECC71"/>
+                </a:solidFill>
+              </a:rPr>
+              <a:t>V  O que os dados mostraram</a:t>
+            </a:r>
+          </a:p>
+        </p:txBody>
+      </p:sp>
+      <p:sp>
+        <p:nvSpPr>
+          <p:cNvPr id="46" name="TextBox 45"/>
+          <p:cNvSpPr txBox="1"/>
+          <p:nvPr/>
+        </p:nvSpPr>
+        <p:spPr>
+          <a:xfrm>
+            <a:off x="6263640" y="5596128"/>
+            <a:ext cx="5394960" cy="502920"/>
+          </a:xfrm>
+          <a:prstGeom prst="rect">
+            <a:avLst/>
+          </a:prstGeom>
+          <a:noFill/>
+        </p:spPr>
+        <p:txBody>
+          <a:bodyPr wrap="square">
+            <a:spAutoFit/>
+          </a:bodyPr>
+          <a:lstStyle/>
+          <a:p>
+            <a:pPr algn="l"/>
+            <a:r>
+              <a:rPr sz="1300" b="0" i="0">
+                <a:solidFill>
+                  <a:srgbClr val="FFFFFF"/>
+                </a:solidFill>
+              </a:rPr>
+              <a:t>Queda em 2021 (7,296 -&gt; 6,888), recuperacao parcial em 2022 (7,028).</a:t>
+            </a:r>
+          </a:p>
+        </p:txBody>
+      </p:sp>
+      <p:sp>
+        <p:nvSpPr>
+          <p:cNvPr id="47" name="TextBox 46"/>
+          <p:cNvSpPr txBox="1"/>
+          <p:nvPr/>
+        </p:nvSpPr>
+        <p:spPr>
+          <a:xfrm>
+            <a:off x="365760" y="6355080"/>
+            <a:ext cx="11430000" cy="320040"/>
+          </a:xfrm>
+          <a:prstGeom prst="rect">
+            <a:avLst/>
+          </a:prstGeom>
+          <a:noFill/>
+        </p:spPr>
+        <p:txBody>
+          <a:bodyPr wrap="square">
+            <a:spAutoFit/>
+          </a:bodyPr>
+          <a:lstStyle/>
+          <a:p>
+            <a:pPr algn="l"/>
+            <a:r>
+              <a:rPr sz="1100" b="0" i="1">
+                <a:solidFill>
+                  <a:srgbClr val="CCD6E0"/>
+                </a:solidFill>
+              </a:rPr>
+              <a:t>Todos os testes nao-parametricos (Spearman + Kruskal-Wallis). Nenhum indicador segue distribuicao normal (Shapiro-Wilk p&lt;0,05).</a:t>
+            </a:r>
+          </a:p>
+        </p:txBody>
+      </p:sp>
+      <p:sp>
+        <p:nvSpPr>
+          <p:cNvPr id="48" name="TextBox 47"/>
+          <p:cNvSpPr txBox="1"/>
+          <p:nvPr/>
+        </p:nvSpPr>
+        <p:spPr>
+          <a:xfrm>
+            <a:off x="11704320" y="6492240"/>
+            <a:ext cx="457200" cy="320040"/>
+          </a:xfrm>
+          <a:prstGeom prst="rect">
+            <a:avLst/>
+          </a:prstGeom>
+          <a:noFill/>
+        </p:spPr>
+        <p:txBody>
+          <a:bodyPr wrap="square">
+            <a:spAutoFit/>
+          </a:bodyPr>
+          <a:lstStyle/>
+          <a:p>
+            <a:pPr algn="r"/>
+            <a:r>
+              <a:rPr sz="1100" b="0" i="0">
+                <a:solidFill>
+                  <a:srgbClr val="CCD6E0"/>
+                </a:solidFill>
+              </a:rPr>
+              <a:t>13</a:t>
             </a:r>
           </a:p>
         </p:txBody>

</xml_diff>